<commit_message>
Audit Workspace & Delivery
</commit_message>
<xml_diff>
--- a/docs/INPROFIC_Pitch_Deck.pptx
+++ b/docs/INPROFIC_Pitch_Deck.pptx
@@ -3118,8 +3118,8 @@
         </p:nvSpPr>
         <p:spPr>
           <a:xfrm>
-            <a:off x="8001000" y="-365760"/>
-            <a:ext cx="4754880" cy="7498079"/>
+            <a:off x="8001000" y="18288"/>
+            <a:ext cx="4160520" cy="6821424"/>
           </a:xfrm>
           <a:prstGeom prst="roundRect">
             <a:avLst>
@@ -3297,7 +3297,7 @@
               </a:defRPr>
             </a:pPr>
             <a:r>
-              <a:t>A production-aware commercial management system for businesses that buy, make, stock, sell and account for value.</a:t>
+              <a:t>A production-aware commercial management system for businesses that buy, make, stock, sell, deliver, audit and account for value.</a:t>
             </a:r>
           </a:p>
         </p:txBody>
@@ -3843,7 +3843,7 @@
               </a:defRPr>
             </a:pPr>
             <a:r>
-              <a:t>Business Admins, configurable roles and module permissions govern visibility; the Founder-only Demo role can explore live workflows without writes.</a:t>
+              <a:t>Business Admins, configurable roles and per-user overrides govern visibility; POS-only staff, delivery riders and external auditors enter purpose-built workspaces.</a:t>
             </a:r>
           </a:p>
         </p:txBody>
@@ -4215,7 +4215,7 @@
         <p:spPr>
           <a:xfrm>
             <a:off x="713232" y="1481328"/>
-            <a:ext cx="3401568" cy="1554480"/>
+            <a:ext cx="2487168" cy="1554480"/>
           </a:xfrm>
           <a:prstGeom prst="roundRect">
             <a:avLst>
@@ -4262,7 +4262,7 @@
         <p:spPr>
           <a:xfrm>
             <a:off x="941832" y="1828800"/>
-            <a:ext cx="2926080" cy="320040"/>
+            <a:ext cx="2011680" cy="320040"/>
           </a:xfrm>
           <a:prstGeom prst="rect">
             <a:avLst/>
@@ -4298,7 +4298,7 @@
         <p:spPr>
           <a:xfrm>
             <a:off x="941832" y="2340864"/>
-            <a:ext cx="2880360" cy="384048"/>
+            <a:ext cx="1965960" cy="384048"/>
           </a:xfrm>
           <a:prstGeom prst="rect">
             <a:avLst/>
@@ -4333,8 +4333,8 @@
         </p:nvSpPr>
         <p:spPr>
           <a:xfrm>
-            <a:off x="4480560" y="1481328"/>
-            <a:ext cx="3401568" cy="1554480"/>
+            <a:off x="3493008" y="1481328"/>
+            <a:ext cx="2487168" cy="1554480"/>
           </a:xfrm>
           <a:prstGeom prst="roundRect">
             <a:avLst>
@@ -4380,8 +4380,8 @@
         </p:nvSpPr>
         <p:spPr>
           <a:xfrm>
-            <a:off x="4709160" y="1828800"/>
-            <a:ext cx="2926080" cy="320040"/>
+            <a:off x="3721608" y="1828800"/>
+            <a:ext cx="2011680" cy="320040"/>
           </a:xfrm>
           <a:prstGeom prst="rect">
             <a:avLst/>
@@ -4416,8 +4416,8 @@
         </p:nvSpPr>
         <p:spPr>
           <a:xfrm>
-            <a:off x="4709160" y="2340864"/>
-            <a:ext cx="2880360" cy="384048"/>
+            <a:off x="3721608" y="2340864"/>
+            <a:ext cx="1965960" cy="384048"/>
           </a:xfrm>
           <a:prstGeom prst="rect">
             <a:avLst/>
@@ -4452,8 +4452,8 @@
         </p:nvSpPr>
         <p:spPr>
           <a:xfrm>
-            <a:off x="8247888" y="1481328"/>
-            <a:ext cx="3401568" cy="1554480"/>
+            <a:off x="6272784" y="1481328"/>
+            <a:ext cx="2487168" cy="1554480"/>
           </a:xfrm>
           <a:prstGeom prst="roundRect">
             <a:avLst>
@@ -4499,8 +4499,8 @@
         </p:nvSpPr>
         <p:spPr>
           <a:xfrm>
-            <a:off x="8476488" y="1828800"/>
-            <a:ext cx="2926080" cy="320040"/>
+            <a:off x="6501384" y="1828800"/>
+            <a:ext cx="2011680" cy="320040"/>
           </a:xfrm>
           <a:prstGeom prst="rect">
             <a:avLst/>
@@ -4535,8 +4535,8 @@
         </p:nvSpPr>
         <p:spPr>
           <a:xfrm>
-            <a:off x="8476488" y="2340864"/>
-            <a:ext cx="2880360" cy="384048"/>
+            <a:off x="6501384" y="2340864"/>
+            <a:ext cx="1965960" cy="384048"/>
           </a:xfrm>
           <a:prstGeom prst="rect">
             <a:avLst/>
@@ -4571,8 +4571,8 @@
         </p:nvSpPr>
         <p:spPr>
           <a:xfrm>
-            <a:off x="713232" y="3447288"/>
-            <a:ext cx="3401568" cy="1554480"/>
+            <a:off x="9052560" y="1481328"/>
+            <a:ext cx="2487168" cy="1554480"/>
           </a:xfrm>
           <a:prstGeom prst="roundRect">
             <a:avLst>
@@ -4618,8 +4618,8 @@
         </p:nvSpPr>
         <p:spPr>
           <a:xfrm>
-            <a:off x="941832" y="3794760"/>
-            <a:ext cx="2926080" cy="320040"/>
+            <a:off x="9281160" y="1828800"/>
+            <a:ext cx="2011680" cy="320040"/>
           </a:xfrm>
           <a:prstGeom prst="rect">
             <a:avLst/>
@@ -4654,8 +4654,8 @@
         </p:nvSpPr>
         <p:spPr>
           <a:xfrm>
-            <a:off x="941832" y="4306824"/>
-            <a:ext cx="2880360" cy="384048"/>
+            <a:off x="9281160" y="2340864"/>
+            <a:ext cx="1965960" cy="384048"/>
           </a:xfrm>
           <a:prstGeom prst="rect">
             <a:avLst/>
@@ -4690,8 +4690,8 @@
         </p:nvSpPr>
         <p:spPr>
           <a:xfrm>
-            <a:off x="4480560" y="3447288"/>
-            <a:ext cx="3401568" cy="1554480"/>
+            <a:off x="713232" y="3447288"/>
+            <a:ext cx="2487168" cy="1554480"/>
           </a:xfrm>
           <a:prstGeom prst="roundRect">
             <a:avLst>
@@ -4737,8 +4737,8 @@
         </p:nvSpPr>
         <p:spPr>
           <a:xfrm>
-            <a:off x="4709160" y="3794760"/>
-            <a:ext cx="2926080" cy="320040"/>
+            <a:off x="941832" y="3794760"/>
+            <a:ext cx="2011680" cy="320040"/>
           </a:xfrm>
           <a:prstGeom prst="rect">
             <a:avLst/>
@@ -4773,8 +4773,8 @@
         </p:nvSpPr>
         <p:spPr>
           <a:xfrm>
-            <a:off x="4709160" y="4306824"/>
-            <a:ext cx="2880360" cy="384048"/>
+            <a:off x="941832" y="4306824"/>
+            <a:ext cx="1965960" cy="384048"/>
           </a:xfrm>
           <a:prstGeom prst="rect">
             <a:avLst/>
@@ -4809,8 +4809,8 @@
         </p:nvSpPr>
         <p:spPr>
           <a:xfrm>
-            <a:off x="8247888" y="3447288"/>
-            <a:ext cx="3401568" cy="1554480"/>
+            <a:off x="3493008" y="3447288"/>
+            <a:ext cx="2487168" cy="1554480"/>
           </a:xfrm>
           <a:prstGeom prst="roundRect">
             <a:avLst>
@@ -4856,8 +4856,8 @@
         </p:nvSpPr>
         <p:spPr>
           <a:xfrm>
-            <a:off x="8476488" y="3794760"/>
-            <a:ext cx="2926080" cy="320040"/>
+            <a:off x="3721608" y="3794760"/>
+            <a:ext cx="2011680" cy="320040"/>
           </a:xfrm>
           <a:prstGeom prst="rect">
             <a:avLst/>
@@ -4879,6 +4879,244 @@
               </a:defRPr>
             </a:pPr>
             <a:r>
+              <a:t>↗  Delivery timeline</a:t>
+            </a:r>
+          </a:p>
+        </p:txBody>
+      </p:sp>
+      <p:sp>
+        <p:nvSpPr>
+          <p:cNvPr id="23" name="TextBox 22"/>
+          <p:cNvSpPr txBox="1"/>
+          <p:nvPr/>
+        </p:nvSpPr>
+        <p:spPr>
+          <a:xfrm>
+            <a:off x="3721608" y="4306824"/>
+            <a:ext cx="1965960" cy="384048"/>
+          </a:xfrm>
+          <a:prstGeom prst="rect">
+            <a:avLst/>
+          </a:prstGeom>
+          <a:noFill/>
+        </p:spPr>
+        <p:txBody>
+          <a:bodyPr wrap="square" anchor="t" lIns="18288" rIns="18288" tIns="9144" bIns="9144">
+            <a:spAutoFit/>
+          </a:bodyPr>
+          <a:lstStyle/>
+          <a:p>
+            <a:pPr algn="l">
+              <a:defRPr sz="1050" b="0">
+                <a:solidFill>
+                  <a:srgbClr val="C7C8DD"/>
+                </a:solidFill>
+                <a:latin typeface="Aptos"/>
+              </a:defRPr>
+            </a:pPr>
+            <a:r>
+              <a:t>Same business scope and status logic as the operating screen.</a:t>
+            </a:r>
+          </a:p>
+        </p:txBody>
+      </p:sp>
+      <p:sp>
+        <p:nvSpPr>
+          <p:cNvPr id="24" name="Rounded Rectangle 23"/>
+          <p:cNvSpPr/>
+          <p:nvPr/>
+        </p:nvSpPr>
+        <p:spPr>
+          <a:xfrm>
+            <a:off x="6272784" y="3447288"/>
+            <a:ext cx="2487168" cy="1554480"/>
+          </a:xfrm>
+          <a:prstGeom prst="roundRect">
+            <a:avLst>
+              <a:gd name="adj" fmla="val 8000"/>
+            </a:avLst>
+          </a:prstGeom>
+          <a:solidFill>
+            <a:srgbClr val="111347"/>
+          </a:solidFill>
+          <a:ln>
+            <a:solidFill>
+              <a:srgbClr val="292B62"/>
+            </a:solidFill>
+          </a:ln>
+        </p:spPr>
+        <p:style>
+          <a:lnRef idx="1">
+            <a:schemeClr val="accent1"/>
+          </a:lnRef>
+          <a:fillRef idx="3">
+            <a:schemeClr val="accent1"/>
+          </a:fillRef>
+          <a:effectRef idx="2">
+            <a:schemeClr val="accent1"/>
+          </a:effectRef>
+          <a:fontRef idx="minor">
+            <a:schemeClr val="lt1"/>
+          </a:fontRef>
+        </p:style>
+        <p:txBody>
+          <a:bodyPr rtlCol="0" anchor="ctr"/>
+          <a:lstStyle/>
+          <a:p>
+            <a:pPr algn="ctr"/>
+          </a:p>
+        </p:txBody>
+      </p:sp>
+      <p:sp>
+        <p:nvSpPr>
+          <p:cNvPr id="25" name="TextBox 24"/>
+          <p:cNvSpPr txBox="1"/>
+          <p:nvPr/>
+        </p:nvSpPr>
+        <p:spPr>
+          <a:xfrm>
+            <a:off x="6501384" y="3794760"/>
+            <a:ext cx="2011680" cy="320040"/>
+          </a:xfrm>
+          <a:prstGeom prst="rect">
+            <a:avLst/>
+          </a:prstGeom>
+          <a:noFill/>
+        </p:spPr>
+        <p:txBody>
+          <a:bodyPr wrap="square" anchor="t" lIns="18288" rIns="18288" tIns="9144" bIns="9144">
+            <a:spAutoFit/>
+          </a:bodyPr>
+          <a:lstStyle/>
+          <a:p>
+            <a:pPr algn="l">
+              <a:defRPr sz="1600" b="1">
+                <a:solidFill>
+                  <a:srgbClr val="FFFFFF"/>
+                </a:solidFill>
+                <a:latin typeface="Aptos"/>
+              </a:defRPr>
+            </a:pPr>
+            <a:r>
+              <a:t>↗  Audit queries</a:t>
+            </a:r>
+          </a:p>
+        </p:txBody>
+      </p:sp>
+      <p:sp>
+        <p:nvSpPr>
+          <p:cNvPr id="26" name="TextBox 25"/>
+          <p:cNvSpPr txBox="1"/>
+          <p:nvPr/>
+        </p:nvSpPr>
+        <p:spPr>
+          <a:xfrm>
+            <a:off x="6501384" y="4306824"/>
+            <a:ext cx="1965960" cy="384048"/>
+          </a:xfrm>
+          <a:prstGeom prst="rect">
+            <a:avLst/>
+          </a:prstGeom>
+          <a:noFill/>
+        </p:spPr>
+        <p:txBody>
+          <a:bodyPr wrap="square" anchor="t" lIns="18288" rIns="18288" tIns="9144" bIns="9144">
+            <a:spAutoFit/>
+          </a:bodyPr>
+          <a:lstStyle/>
+          <a:p>
+            <a:pPr algn="l">
+              <a:defRPr sz="1050" b="0">
+                <a:solidFill>
+                  <a:srgbClr val="C7C8DD"/>
+                </a:solidFill>
+                <a:latin typeface="Aptos"/>
+              </a:defRPr>
+            </a:pPr>
+            <a:r>
+              <a:t>Same business scope and status logic as the operating screen.</a:t>
+            </a:r>
+          </a:p>
+        </p:txBody>
+      </p:sp>
+      <p:sp>
+        <p:nvSpPr>
+          <p:cNvPr id="27" name="Rounded Rectangle 26"/>
+          <p:cNvSpPr/>
+          <p:nvPr/>
+        </p:nvSpPr>
+        <p:spPr>
+          <a:xfrm>
+            <a:off x="9052560" y="3447288"/>
+            <a:ext cx="2487168" cy="1554480"/>
+          </a:xfrm>
+          <a:prstGeom prst="roundRect">
+            <a:avLst>
+              <a:gd name="adj" fmla="val 8000"/>
+            </a:avLst>
+          </a:prstGeom>
+          <a:solidFill>
+            <a:srgbClr val="111347"/>
+          </a:solidFill>
+          <a:ln>
+            <a:solidFill>
+              <a:srgbClr val="292B62"/>
+            </a:solidFill>
+          </a:ln>
+        </p:spPr>
+        <p:style>
+          <a:lnRef idx="1">
+            <a:schemeClr val="accent1"/>
+          </a:lnRef>
+          <a:fillRef idx="3">
+            <a:schemeClr val="accent1"/>
+          </a:fillRef>
+          <a:effectRef idx="2">
+            <a:schemeClr val="accent1"/>
+          </a:effectRef>
+          <a:fontRef idx="minor">
+            <a:schemeClr val="lt1"/>
+          </a:fontRef>
+        </p:style>
+        <p:txBody>
+          <a:bodyPr rtlCol="0" anchor="ctr"/>
+          <a:lstStyle/>
+          <a:p>
+            <a:pPr algn="ctr"/>
+          </a:p>
+        </p:txBody>
+      </p:sp>
+      <p:sp>
+        <p:nvSpPr>
+          <p:cNvPr id="28" name="TextBox 27"/>
+          <p:cNvSpPr txBox="1"/>
+          <p:nvPr/>
+        </p:nvSpPr>
+        <p:spPr>
+          <a:xfrm>
+            <a:off x="9281160" y="3794760"/>
+            <a:ext cx="2011680" cy="320040"/>
+          </a:xfrm>
+          <a:prstGeom prst="rect">
+            <a:avLst/>
+          </a:prstGeom>
+          <a:noFill/>
+        </p:spPr>
+        <p:txBody>
+          <a:bodyPr wrap="square" anchor="t" lIns="18288" rIns="18288" tIns="9144" bIns="9144">
+            <a:spAutoFit/>
+          </a:bodyPr>
+          <a:lstStyle/>
+          <a:p>
+            <a:pPr algn="l">
+              <a:defRPr sz="1600" b="1">
+                <a:solidFill>
+                  <a:srgbClr val="FFFFFF"/>
+                </a:solidFill>
+                <a:latin typeface="Aptos"/>
+              </a:defRPr>
+            </a:pPr>
+            <a:r>
               <a:t>↗  CSV / XLSX / JSON backup</a:t>
             </a:r>
           </a:p>
@@ -4886,14 +5124,14 @@
       </p:sp>
       <p:sp>
         <p:nvSpPr>
-          <p:cNvPr id="23" name="TextBox 22"/>
-          <p:cNvSpPr txBox="1"/>
-          <p:nvPr/>
-        </p:nvSpPr>
-        <p:spPr>
-          <a:xfrm>
-            <a:off x="8476488" y="4306824"/>
-            <a:ext cx="2880360" cy="384048"/>
+          <p:cNvPr id="29" name="TextBox 28"/>
+          <p:cNvSpPr txBox="1"/>
+          <p:nvPr/>
+        </p:nvSpPr>
+        <p:spPr>
+          <a:xfrm>
+            <a:off x="9281160" y="4306824"/>
+            <a:ext cx="1965960" cy="384048"/>
           </a:xfrm>
           <a:prstGeom prst="rect">
             <a:avLst/>
@@ -5311,7 +5549,7 @@
               </a:defRPr>
             </a:pPr>
             <a:r>
-              <a:t>Accounts • Inventory • Procurement • Production • Sales • Expenses • Commerce • Reports</a:t>
+              <a:t>Accounts • Inventory • Procurement • Production • Sales • Expenses • Commerce • Delivery • Audit • Reports</a:t>
             </a:r>
           </a:p>
         </p:txBody>
@@ -6307,7 +6545,7 @@
               </a:defRPr>
             </a:pPr>
             <a:r>
-              <a:t>All modules, including Finance and Commerce</a:t>
+              <a:t>All core modules, plus Founder-toggled Delivery and Audit Workspace</a:t>
             </a:r>
           </a:p>
         </p:txBody>
@@ -6379,7 +6617,7 @@
               </a:defRPr>
             </a:pPr>
             <a:r>
-              <a:t>30-day trial • founder-controlled pricing &amp; timed promos • animated public campaign creative • monthly/yearly billing</a:t>
+              <a:t>30-day trial • founder-controlled pricing • plan-gated Delivery and Audit add-ons • monthly/yearly billing</a:t>
             </a:r>
           </a:p>
         </p:txBody>
@@ -7029,7 +7267,7 @@
               </a:defRPr>
             </a:pPr>
             <a:r>
-              <a:t>Stock, payments and corrections retain accountable history.</a:t>
+              <a:t>Stock, payments, delivery events, record-bound auditor queries and corrections retain accountable history.</a:t>
             </a:r>
           </a:p>
         </p:txBody>
@@ -7193,7 +7431,7 @@
               </a:defRPr>
             </a:pPr>
             <a:r>
-              <a:t>Five verticals, modular entitlements, Founder-managed promo campaigns and two supported deployment paths.</a:t>
+              <a:t>Five verticals, product categories, modular entitlements, in-house rider operations, true Hybrid routing and Glovo LaaS v2.</a:t>
             </a:r>
           </a:p>
         </p:txBody>
@@ -7700,7 +7938,7 @@
               </a:defRPr>
             </a:pPr>
             <a:r>
-              <a:t>Inventory • Procurement • Production • Finance • Commerce</a:t>
+              <a:t>Inventory • Procurement • Production • Finance • Commerce • Delivery • Audit</a:t>
             </a:r>
           </a:p>
         </p:txBody>
@@ -8713,7 +8951,7 @@
         <p:spPr>
           <a:xfrm>
             <a:off x="640080" y="1874519"/>
-            <a:ext cx="1965960" cy="2240280"/>
+            <a:ext cx="1600200" cy="2240280"/>
           </a:xfrm>
           <a:prstGeom prst="roundRect">
             <a:avLst>
@@ -8796,7 +9034,7 @@
         <p:spPr>
           <a:xfrm>
             <a:off x="822959" y="2596896"/>
-            <a:ext cx="1600200" cy="320040"/>
+            <a:ext cx="1234440" cy="320040"/>
           </a:xfrm>
           <a:prstGeom prst="rect">
             <a:avLst/>
@@ -8832,7 +9070,7 @@
         <p:spPr>
           <a:xfrm>
             <a:off x="822959" y="3090672"/>
-            <a:ext cx="1600200" cy="594360"/>
+            <a:ext cx="1234440" cy="594360"/>
           </a:xfrm>
           <a:prstGeom prst="rect">
             <a:avLst/>
@@ -8871,8 +9109,8 @@
         </p:nvSpPr>
         <p:spPr>
           <a:xfrm>
-            <a:off x="2633472" y="2798064"/>
-            <a:ext cx="384048" cy="320040"/>
+            <a:off x="2267712" y="2798064"/>
+            <a:ext cx="274320" cy="320040"/>
           </a:xfrm>
           <a:prstGeom prst="rightArrow">
             <a:avLst/>
@@ -8916,8 +9154,8 @@
         </p:nvSpPr>
         <p:spPr>
           <a:xfrm>
-            <a:off x="2926080" y="1874519"/>
-            <a:ext cx="1965960" cy="2240280"/>
+            <a:off x="2514600" y="1874519"/>
+            <a:ext cx="1600200" cy="2240280"/>
           </a:xfrm>
           <a:prstGeom prst="roundRect">
             <a:avLst>
@@ -8963,7 +9201,7 @@
         </p:nvSpPr>
         <p:spPr>
           <a:xfrm>
-            <a:off x="3108960" y="2084831"/>
+            <a:off x="2697480" y="2084831"/>
             <a:ext cx="365760" cy="228600"/>
           </a:xfrm>
           <a:prstGeom prst="rect">
@@ -8999,8 +9237,8 @@
         </p:nvSpPr>
         <p:spPr>
           <a:xfrm>
-            <a:off x="3108960" y="2596896"/>
-            <a:ext cx="1600200" cy="320040"/>
+            <a:off x="2697480" y="2596896"/>
+            <a:ext cx="1234440" cy="320040"/>
           </a:xfrm>
           <a:prstGeom prst="rect">
             <a:avLst/>
@@ -9035,8 +9273,8 @@
         </p:nvSpPr>
         <p:spPr>
           <a:xfrm>
-            <a:off x="3108960" y="3090672"/>
-            <a:ext cx="1600200" cy="594360"/>
+            <a:off x="2697480" y="3090672"/>
+            <a:ext cx="1234440" cy="594360"/>
           </a:xfrm>
           <a:prstGeom prst="rect">
             <a:avLst/>
@@ -9075,8 +9313,8 @@
         </p:nvSpPr>
         <p:spPr>
           <a:xfrm>
-            <a:off x="4919472" y="2798064"/>
-            <a:ext cx="384048" cy="320040"/>
+            <a:off x="4142232" y="2798064"/>
+            <a:ext cx="274320" cy="320040"/>
           </a:xfrm>
           <a:prstGeom prst="rightArrow">
             <a:avLst/>
@@ -9120,8 +9358,8 @@
         </p:nvSpPr>
         <p:spPr>
           <a:xfrm>
-            <a:off x="5212080" y="1874519"/>
-            <a:ext cx="1965960" cy="2240280"/>
+            <a:off x="4389120" y="1874519"/>
+            <a:ext cx="1600200" cy="2240280"/>
           </a:xfrm>
           <a:prstGeom prst="roundRect">
             <a:avLst>
@@ -9167,7 +9405,7 @@
         </p:nvSpPr>
         <p:spPr>
           <a:xfrm>
-            <a:off x="5394960" y="2084831"/>
+            <a:off x="4572000" y="2084831"/>
             <a:ext cx="365760" cy="228600"/>
           </a:xfrm>
           <a:prstGeom prst="rect">
@@ -9203,8 +9441,8 @@
         </p:nvSpPr>
         <p:spPr>
           <a:xfrm>
-            <a:off x="5394960" y="2596896"/>
-            <a:ext cx="1600200" cy="320040"/>
+            <a:off x="4572000" y="2596896"/>
+            <a:ext cx="1234440" cy="320040"/>
           </a:xfrm>
           <a:prstGeom prst="rect">
             <a:avLst/>
@@ -9239,8 +9477,8 @@
         </p:nvSpPr>
         <p:spPr>
           <a:xfrm>
-            <a:off x="5394960" y="3090672"/>
-            <a:ext cx="1600200" cy="594360"/>
+            <a:off x="4572000" y="3090672"/>
+            <a:ext cx="1234440" cy="594360"/>
           </a:xfrm>
           <a:prstGeom prst="rect">
             <a:avLst/>
@@ -9279,8 +9517,8 @@
         </p:nvSpPr>
         <p:spPr>
           <a:xfrm>
-            <a:off x="7205472" y="2798064"/>
-            <a:ext cx="384048" cy="320040"/>
+            <a:off x="6016752" y="2798064"/>
+            <a:ext cx="274320" cy="320040"/>
           </a:xfrm>
           <a:prstGeom prst="rightArrow">
             <a:avLst/>
@@ -9324,8 +9562,8 @@
         </p:nvSpPr>
         <p:spPr>
           <a:xfrm>
-            <a:off x="7498079" y="1874519"/>
-            <a:ext cx="1965960" cy="2240280"/>
+            <a:off x="6263640" y="1874519"/>
+            <a:ext cx="1600200" cy="2240280"/>
           </a:xfrm>
           <a:prstGeom prst="roundRect">
             <a:avLst>
@@ -9371,7 +9609,7 @@
         </p:nvSpPr>
         <p:spPr>
           <a:xfrm>
-            <a:off x="7680959" y="2084831"/>
+            <a:off x="6446520" y="2084831"/>
             <a:ext cx="365760" cy="228600"/>
           </a:xfrm>
           <a:prstGeom prst="rect">
@@ -9407,8 +9645,8 @@
         </p:nvSpPr>
         <p:spPr>
           <a:xfrm>
-            <a:off x="7680959" y="2596896"/>
-            <a:ext cx="1600200" cy="320040"/>
+            <a:off x="6446520" y="2596896"/>
+            <a:ext cx="1234440" cy="320040"/>
           </a:xfrm>
           <a:prstGeom prst="rect">
             <a:avLst/>
@@ -9443,8 +9681,8 @@
         </p:nvSpPr>
         <p:spPr>
           <a:xfrm>
-            <a:off x="7680959" y="3090672"/>
-            <a:ext cx="1600200" cy="594360"/>
+            <a:off x="6446520" y="3090672"/>
+            <a:ext cx="1234440" cy="594360"/>
           </a:xfrm>
           <a:prstGeom prst="rect">
             <a:avLst/>
@@ -9483,8 +9721,8 @@
         </p:nvSpPr>
         <p:spPr>
           <a:xfrm>
-            <a:off x="9491472" y="2798064"/>
-            <a:ext cx="384048" cy="320040"/>
+            <a:off x="7891271" y="2798064"/>
+            <a:ext cx="274320" cy="320040"/>
           </a:xfrm>
           <a:prstGeom prst="rightArrow">
             <a:avLst/>
@@ -9528,8 +9766,8 @@
         </p:nvSpPr>
         <p:spPr>
           <a:xfrm>
-            <a:off x="9784080" y="1874519"/>
-            <a:ext cx="1965960" cy="2240280"/>
+            <a:off x="8138159" y="1874519"/>
+            <a:ext cx="1600200" cy="2240280"/>
           </a:xfrm>
           <a:prstGeom prst="roundRect">
             <a:avLst>
@@ -9575,7 +9813,7 @@
         </p:nvSpPr>
         <p:spPr>
           <a:xfrm>
-            <a:off x="9966959" y="2084831"/>
+            <a:off x="8321039" y="2084831"/>
             <a:ext cx="365760" cy="228600"/>
           </a:xfrm>
           <a:prstGeom prst="rect">
@@ -9611,8 +9849,8 @@
         </p:nvSpPr>
         <p:spPr>
           <a:xfrm>
-            <a:off x="9966959" y="2596896"/>
-            <a:ext cx="1600200" cy="320040"/>
+            <a:off x="8321039" y="2596896"/>
+            <a:ext cx="1234440" cy="320040"/>
           </a:xfrm>
           <a:prstGeom prst="rect">
             <a:avLst/>
@@ -9647,8 +9885,8 @@
         </p:nvSpPr>
         <p:spPr>
           <a:xfrm>
-            <a:off x="9966959" y="3090672"/>
-            <a:ext cx="1600200" cy="594360"/>
+            <a:off x="8321039" y="3090672"/>
+            <a:ext cx="1234440" cy="594360"/>
           </a:xfrm>
           <a:prstGeom prst="rect">
             <a:avLst/>
@@ -9710,7 +9948,7 @@
               </a:defRPr>
             </a:pPr>
             <a:r>
-              <a:t>Each event updates the next layer without losing the business, customer, product or audit context.</a:t>
+              <a:t>Each event updates the next layer without losing the business, customer, product, delivery or audit context.</a:t>
             </a:r>
           </a:p>
         </p:txBody>
@@ -13992,7 +14230,7 @@
               </a:defRPr>
             </a:pPr>
             <a:r>
-              <a:t>Published catalogues, baskets, channel pricing, payment and saved order tracking.</a:t>
+              <a:t>Published catalogues, baskets, channel pricing, guest checkout, optional tenant-scoped customer profiles and saved order tracking.</a:t>
             </a:r>
           </a:p>
         </p:txBody>
@@ -14823,7 +15061,7 @@
               </a:defRPr>
             </a:pPr>
             <a:r>
-              <a:t>Hosted storefront • Order Now link • Headless API • Signed platform connector</a:t>
+              <a:t>Hosted storefront • Customer profiles optional • Product categories • POS-only/supplemental access • Headless API</a:t>
             </a:r>
           </a:p>
         </p:txBody>

</xml_diff>